<commit_message>
feat: diag EDT 消融实验 + fair test CNN-DDQN+MD vs baselines
- 9 变体 diag EDT 消融训练/推理配置 + 结果组织 (paperruns/diag/)
- fair test: CNN-DDQN+MD vs RRT* vs LO-HA* rollout timing 50 runs
- 分析脚本去除归一化，仅保留原始指标
- MHA/Dueling 模块拆分到 modules.py
- 自行车模型 PPT 作图
</commit_message>
<xml_diff>
--- a/paperdqn8.3/media/fig2_platform.pptx
+++ b/paperdqn8.3/media/fig2_platform.pptx
@@ -1,13 +1,13 @@
 
 <file path=ppt/presentation.xml><?xml version="1.0" encoding="utf-8"?>
-<p:presentation xmlns:a="http://schemas.openxmlformats.org/drawingml/2006/main" xmlns:r="http://schemas.openxmlformats.org/officeDocument/2006/relationships" xmlns:p="http://schemas.openxmlformats.org/presentationml/2006/main" autoCompressPictures="0">
+<p:presentation xmlns:a="http://schemas.openxmlformats.org/drawingml/2006/main" xmlns:r="http://schemas.openxmlformats.org/officeDocument/2006/relationships" xmlns:p="http://schemas.openxmlformats.org/presentationml/2006/main" saveSubsetFonts="1" autoCompressPictures="0">
   <p:sldMasterIdLst>
     <p:sldMasterId id="2147483648" r:id="rId1"/>
   </p:sldMasterIdLst>
   <p:sldIdLst>
-    <p:sldId id="256" r:id="rId3"/>
+    <p:sldId id="256" r:id="rId7"/>
   </p:sldIdLst>
-  <p:sldSz cx="5029200" cy="4114800" type="screen4x3"/>
+  <p:sldSz cx="6858000" cy="4114800" type="screen4x3"/>
   <p:notesSz cx="6858000" cy="9144000"/>
   <p:defaultTextStyle>
     <a:defPPr>
@@ -104,22 +104,6 @@
       </a:defRPr>
     </a:lvl9pPr>
   </p:defaultTextStyle>
-  <p:extLst>
-    <p:ext uri="{EFAFB233-063F-42B5-8137-9DF3F51BA10A}">
-      <p15:sldGuideLst xmlns:p15="http://schemas.microsoft.com/office/powerpoint/2012/main">
-        <p15:guide id="1" orient="horz" pos="2160" userDrawn="1">
-          <p15:clr>
-            <a:srgbClr val="A4A3A4"/>
-          </p15:clr>
-        </p15:guide>
-        <p15:guide id="2" pos="2880" userDrawn="1">
-          <p15:clr>
-            <a:srgbClr val="A4A3A4"/>
-          </p15:clr>
-        </p15:guide>
-      </p15:sldGuideLst>
-    </p:ext>
-  </p:extLst>
 </p:presentation>
 </file>
 
@@ -304,6 +288,7 @@
           <a:p>
             <a:fld id="{5BCAD085-E8A6-8845-BD4E-CB4CCA059FC4}" type="datetimeFigureOut">
               <a:rPr lang="en-US" smtClean="0"/>
+              <a:t>1/27/13</a:t>
             </a:fld>
             <a:endParaRPr lang="en-US"/>
           </a:p>
@@ -345,12 +330,18 @@
           <a:p>
             <a:fld id="{C1FF6DA9-008F-8B48-92A6-B652298478BF}" type="slidenum">
               <a:rPr lang="en-US" smtClean="0"/>
+              <a:t>‹#›</a:t>
             </a:fld>
             <a:endParaRPr lang="en-US"/>
           </a:p>
         </p:txBody>
       </p:sp>
     </p:spTree>
+    <p:extLst>
+      <p:ext uri="{BB962C8B-B14F-4D97-AF65-F5344CB8AC3E}">
+        <p14:creationId xmlns:p14="http://schemas.microsoft.com/office/powerpoint/2010/main" val="3168075583"/>
+      </p:ext>
+    </p:extLst>
   </p:cSld>
   <p:clrMapOvr>
     <a:masterClrMapping/>
@@ -418,7 +409,6 @@
               <a:rPr lang="en-US" smtClean="0"/>
               <a:t>Click to edit Master text styles</a:t>
             </a:r>
-            <a:endParaRPr lang="en-US" smtClean="0"/>
           </a:p>
           <a:p>
             <a:pPr lvl="1"/>
@@ -426,7 +416,6 @@
               <a:rPr lang="en-US" smtClean="0"/>
               <a:t>Second level</a:t>
             </a:r>
-            <a:endParaRPr lang="en-US" smtClean="0"/>
           </a:p>
           <a:p>
             <a:pPr lvl="2"/>
@@ -434,7 +423,6 @@
               <a:rPr lang="en-US" smtClean="0"/>
               <a:t>Third level</a:t>
             </a:r>
-            <a:endParaRPr lang="en-US" smtClean="0"/>
           </a:p>
           <a:p>
             <a:pPr lvl="3"/>
@@ -442,7 +430,6 @@
               <a:rPr lang="en-US" smtClean="0"/>
               <a:t>Fourth level</a:t>
             </a:r>
-            <a:endParaRPr lang="en-US" smtClean="0"/>
           </a:p>
           <a:p>
             <a:pPr lvl="4"/>
@@ -471,6 +458,7 @@
           <a:p>
             <a:fld id="{5BCAD085-E8A6-8845-BD4E-CB4CCA059FC4}" type="datetimeFigureOut">
               <a:rPr lang="en-US" smtClean="0"/>
+              <a:t>1/27/13</a:t>
             </a:fld>
             <a:endParaRPr lang="en-US"/>
           </a:p>
@@ -512,12 +500,18 @@
           <a:p>
             <a:fld id="{C1FF6DA9-008F-8B48-92A6-B652298478BF}" type="slidenum">
               <a:rPr lang="en-US" smtClean="0"/>
+              <a:t>‹#›</a:t>
             </a:fld>
             <a:endParaRPr lang="en-US"/>
           </a:p>
         </p:txBody>
       </p:sp>
     </p:spTree>
+    <p:extLst>
+      <p:ext uri="{BB962C8B-B14F-4D97-AF65-F5344CB8AC3E}">
+        <p14:creationId xmlns:p14="http://schemas.microsoft.com/office/powerpoint/2010/main" val="2910927964"/>
+      </p:ext>
+    </p:extLst>
   </p:cSld>
   <p:clrMapOvr>
     <a:masterClrMapping/>
@@ -595,7 +589,6 @@
               <a:rPr lang="en-US" smtClean="0"/>
               <a:t>Click to edit Master text styles</a:t>
             </a:r>
-            <a:endParaRPr lang="en-US" smtClean="0"/>
           </a:p>
           <a:p>
             <a:pPr lvl="1"/>
@@ -603,7 +596,6 @@
               <a:rPr lang="en-US" smtClean="0"/>
               <a:t>Second level</a:t>
             </a:r>
-            <a:endParaRPr lang="en-US" smtClean="0"/>
           </a:p>
           <a:p>
             <a:pPr lvl="2"/>
@@ -611,7 +603,6 @@
               <a:rPr lang="en-US" smtClean="0"/>
               <a:t>Third level</a:t>
             </a:r>
-            <a:endParaRPr lang="en-US" smtClean="0"/>
           </a:p>
           <a:p>
             <a:pPr lvl="3"/>
@@ -619,7 +610,6 @@
               <a:rPr lang="en-US" smtClean="0"/>
               <a:t>Fourth level</a:t>
             </a:r>
-            <a:endParaRPr lang="en-US" smtClean="0"/>
           </a:p>
           <a:p>
             <a:pPr lvl="4"/>
@@ -648,6 +638,7 @@
           <a:p>
             <a:fld id="{5BCAD085-E8A6-8845-BD4E-CB4CCA059FC4}" type="datetimeFigureOut">
               <a:rPr lang="en-US" smtClean="0"/>
+              <a:t>1/27/13</a:t>
             </a:fld>
             <a:endParaRPr lang="en-US"/>
           </a:p>
@@ -689,12 +680,18 @@
           <a:p>
             <a:fld id="{C1FF6DA9-008F-8B48-92A6-B652298478BF}" type="slidenum">
               <a:rPr lang="en-US" smtClean="0"/>
+              <a:t>‹#›</a:t>
             </a:fld>
             <a:endParaRPr lang="en-US"/>
           </a:p>
         </p:txBody>
       </p:sp>
     </p:spTree>
+    <p:extLst>
+      <p:ext uri="{BB962C8B-B14F-4D97-AF65-F5344CB8AC3E}">
+        <p14:creationId xmlns:p14="http://schemas.microsoft.com/office/powerpoint/2010/main" val="3612223792"/>
+      </p:ext>
+    </p:extLst>
   </p:cSld>
   <p:clrMapOvr>
     <a:masterClrMapping/>
@@ -762,7 +759,6 @@
               <a:rPr lang="en-US" smtClean="0"/>
               <a:t>Click to edit Master text styles</a:t>
             </a:r>
-            <a:endParaRPr lang="en-US" smtClean="0"/>
           </a:p>
           <a:p>
             <a:pPr lvl="1"/>
@@ -770,7 +766,6 @@
               <a:rPr lang="en-US" smtClean="0"/>
               <a:t>Second level</a:t>
             </a:r>
-            <a:endParaRPr lang="en-US" smtClean="0"/>
           </a:p>
           <a:p>
             <a:pPr lvl="2"/>
@@ -778,7 +773,6 @@
               <a:rPr lang="en-US" smtClean="0"/>
               <a:t>Third level</a:t>
             </a:r>
-            <a:endParaRPr lang="en-US" smtClean="0"/>
           </a:p>
           <a:p>
             <a:pPr lvl="3"/>
@@ -786,7 +780,6 @@
               <a:rPr lang="en-US" smtClean="0"/>
               <a:t>Fourth level</a:t>
             </a:r>
-            <a:endParaRPr lang="en-US" smtClean="0"/>
           </a:p>
           <a:p>
             <a:pPr lvl="4"/>
@@ -815,6 +808,7 @@
           <a:p>
             <a:fld id="{5BCAD085-E8A6-8845-BD4E-CB4CCA059FC4}" type="datetimeFigureOut">
               <a:rPr lang="en-US" smtClean="0"/>
+              <a:t>1/27/13</a:t>
             </a:fld>
             <a:endParaRPr lang="en-US"/>
           </a:p>
@@ -856,12 +850,18 @@
           <a:p>
             <a:fld id="{C1FF6DA9-008F-8B48-92A6-B652298478BF}" type="slidenum">
               <a:rPr lang="en-US" smtClean="0"/>
+              <a:t>‹#›</a:t>
             </a:fld>
             <a:endParaRPr lang="en-US"/>
           </a:p>
         </p:txBody>
       </p:sp>
     </p:spTree>
+    <p:extLst>
+      <p:ext uri="{BB962C8B-B14F-4D97-AF65-F5344CB8AC3E}">
+        <p14:creationId xmlns:p14="http://schemas.microsoft.com/office/powerpoint/2010/main" val="2614314258"/>
+      </p:ext>
+    </p:extLst>
   </p:cSld>
   <p:clrMapOvr>
     <a:masterClrMapping/>
@@ -1034,7 +1034,6 @@
               <a:rPr lang="en-US" smtClean="0"/>
               <a:t>Click to edit Master text styles</a:t>
             </a:r>
-            <a:endParaRPr lang="en-US" smtClean="0"/>
           </a:p>
         </p:txBody>
       </p:sp>
@@ -1055,6 +1054,7 @@
           <a:p>
             <a:fld id="{5BCAD085-E8A6-8845-BD4E-CB4CCA059FC4}" type="datetimeFigureOut">
               <a:rPr lang="en-US" smtClean="0"/>
+              <a:t>1/27/13</a:t>
             </a:fld>
             <a:endParaRPr lang="en-US"/>
           </a:p>
@@ -1096,12 +1096,18 @@
           <a:p>
             <a:fld id="{C1FF6DA9-008F-8B48-92A6-B652298478BF}" type="slidenum">
               <a:rPr lang="en-US" smtClean="0"/>
+              <a:t>‹#›</a:t>
             </a:fld>
             <a:endParaRPr lang="en-US"/>
           </a:p>
         </p:txBody>
       </p:sp>
     </p:spTree>
+    <p:extLst>
+      <p:ext uri="{BB962C8B-B14F-4D97-AF65-F5344CB8AC3E}">
+        <p14:creationId xmlns:p14="http://schemas.microsoft.com/office/powerpoint/2010/main" val="960648375"/>
+      </p:ext>
+    </p:extLst>
   </p:cSld>
   <p:clrMapOvr>
     <a:masterClrMapping/>
@@ -1202,7 +1208,6 @@
               <a:rPr lang="en-US" smtClean="0"/>
               <a:t>Click to edit Master text styles</a:t>
             </a:r>
-            <a:endParaRPr lang="en-US" smtClean="0"/>
           </a:p>
           <a:p>
             <a:pPr lvl="1"/>
@@ -1210,7 +1215,6 @@
               <a:rPr lang="en-US" smtClean="0"/>
               <a:t>Second level</a:t>
             </a:r>
-            <a:endParaRPr lang="en-US" smtClean="0"/>
           </a:p>
           <a:p>
             <a:pPr lvl="2"/>
@@ -1218,7 +1222,6 @@
               <a:rPr lang="en-US" smtClean="0"/>
               <a:t>Third level</a:t>
             </a:r>
-            <a:endParaRPr lang="en-US" smtClean="0"/>
           </a:p>
           <a:p>
             <a:pPr lvl="3"/>
@@ -1226,7 +1229,6 @@
               <a:rPr lang="en-US" smtClean="0"/>
               <a:t>Fourth level</a:t>
             </a:r>
-            <a:endParaRPr lang="en-US" smtClean="0"/>
           </a:p>
           <a:p>
             <a:pPr lvl="4"/>
@@ -1291,7 +1293,6 @@
               <a:rPr lang="en-US" smtClean="0"/>
               <a:t>Click to edit Master text styles</a:t>
             </a:r>
-            <a:endParaRPr lang="en-US" smtClean="0"/>
           </a:p>
           <a:p>
             <a:pPr lvl="1"/>
@@ -1299,7 +1300,6 @@
               <a:rPr lang="en-US" smtClean="0"/>
               <a:t>Second level</a:t>
             </a:r>
-            <a:endParaRPr lang="en-US" smtClean="0"/>
           </a:p>
           <a:p>
             <a:pPr lvl="2"/>
@@ -1307,7 +1307,6 @@
               <a:rPr lang="en-US" smtClean="0"/>
               <a:t>Third level</a:t>
             </a:r>
-            <a:endParaRPr lang="en-US" smtClean="0"/>
           </a:p>
           <a:p>
             <a:pPr lvl="3"/>
@@ -1315,7 +1314,6 @@
               <a:rPr lang="en-US" smtClean="0"/>
               <a:t>Fourth level</a:t>
             </a:r>
-            <a:endParaRPr lang="en-US" smtClean="0"/>
           </a:p>
           <a:p>
             <a:pPr lvl="4"/>
@@ -1344,6 +1342,7 @@
           <a:p>
             <a:fld id="{5BCAD085-E8A6-8845-BD4E-CB4CCA059FC4}" type="datetimeFigureOut">
               <a:rPr lang="en-US" smtClean="0"/>
+              <a:t>1/27/13</a:t>
             </a:fld>
             <a:endParaRPr lang="en-US"/>
           </a:p>
@@ -1385,12 +1384,18 @@
           <a:p>
             <a:fld id="{C1FF6DA9-008F-8B48-92A6-B652298478BF}" type="slidenum">
               <a:rPr lang="en-US" smtClean="0"/>
+              <a:t>‹#›</a:t>
             </a:fld>
             <a:endParaRPr lang="en-US"/>
           </a:p>
         </p:txBody>
       </p:sp>
     </p:spTree>
+    <p:extLst>
+      <p:ext uri="{BB962C8B-B14F-4D97-AF65-F5344CB8AC3E}">
+        <p14:creationId xmlns:p14="http://schemas.microsoft.com/office/powerpoint/2010/main" val="2782244947"/>
+      </p:ext>
+    </p:extLst>
   </p:cSld>
   <p:clrMapOvr>
     <a:masterClrMapping/>
@@ -1504,7 +1509,6 @@
               <a:rPr lang="en-US" smtClean="0"/>
               <a:t>Click to edit Master text styles</a:t>
             </a:r>
-            <a:endParaRPr lang="en-US" smtClean="0"/>
           </a:p>
         </p:txBody>
       </p:sp>
@@ -1561,7 +1565,6 @@
               <a:rPr lang="en-US" smtClean="0"/>
               <a:t>Click to edit Master text styles</a:t>
             </a:r>
-            <a:endParaRPr lang="en-US" smtClean="0"/>
           </a:p>
           <a:p>
             <a:pPr lvl="1"/>
@@ -1569,7 +1572,6 @@
               <a:rPr lang="en-US" smtClean="0"/>
               <a:t>Second level</a:t>
             </a:r>
-            <a:endParaRPr lang="en-US" smtClean="0"/>
           </a:p>
           <a:p>
             <a:pPr lvl="2"/>
@@ -1577,7 +1579,6 @@
               <a:rPr lang="en-US" smtClean="0"/>
               <a:t>Third level</a:t>
             </a:r>
-            <a:endParaRPr lang="en-US" smtClean="0"/>
           </a:p>
           <a:p>
             <a:pPr lvl="3"/>
@@ -1585,7 +1586,6 @@
               <a:rPr lang="en-US" smtClean="0"/>
               <a:t>Fourth level</a:t>
             </a:r>
-            <a:endParaRPr lang="en-US" smtClean="0"/>
           </a:p>
           <a:p>
             <a:pPr lvl="4"/>
@@ -1659,7 +1659,6 @@
               <a:rPr lang="en-US" smtClean="0"/>
               <a:t>Click to edit Master text styles</a:t>
             </a:r>
-            <a:endParaRPr lang="en-US" smtClean="0"/>
           </a:p>
         </p:txBody>
       </p:sp>
@@ -1716,7 +1715,6 @@
               <a:rPr lang="en-US" smtClean="0"/>
               <a:t>Click to edit Master text styles</a:t>
             </a:r>
-            <a:endParaRPr lang="en-US" smtClean="0"/>
           </a:p>
           <a:p>
             <a:pPr lvl="1"/>
@@ -1724,7 +1722,6 @@
               <a:rPr lang="en-US" smtClean="0"/>
               <a:t>Second level</a:t>
             </a:r>
-            <a:endParaRPr lang="en-US" smtClean="0"/>
           </a:p>
           <a:p>
             <a:pPr lvl="2"/>
@@ -1732,7 +1729,6 @@
               <a:rPr lang="en-US" smtClean="0"/>
               <a:t>Third level</a:t>
             </a:r>
-            <a:endParaRPr lang="en-US" smtClean="0"/>
           </a:p>
           <a:p>
             <a:pPr lvl="3"/>
@@ -1740,7 +1736,6 @@
               <a:rPr lang="en-US" smtClean="0"/>
               <a:t>Fourth level</a:t>
             </a:r>
-            <a:endParaRPr lang="en-US" smtClean="0"/>
           </a:p>
           <a:p>
             <a:pPr lvl="4"/>
@@ -1769,6 +1764,7 @@
           <a:p>
             <a:fld id="{5BCAD085-E8A6-8845-BD4E-CB4CCA059FC4}" type="datetimeFigureOut">
               <a:rPr lang="en-US" smtClean="0"/>
+              <a:t>1/27/13</a:t>
             </a:fld>
             <a:endParaRPr lang="en-US"/>
           </a:p>
@@ -1810,12 +1806,18 @@
           <a:p>
             <a:fld id="{C1FF6DA9-008F-8B48-92A6-B652298478BF}" type="slidenum">
               <a:rPr lang="en-US" smtClean="0"/>
+              <a:t>‹#›</a:t>
             </a:fld>
             <a:endParaRPr lang="en-US"/>
           </a:p>
         </p:txBody>
       </p:sp>
     </p:spTree>
+    <p:extLst>
+      <p:ext uri="{BB962C8B-B14F-4D97-AF65-F5344CB8AC3E}">
+        <p14:creationId xmlns:p14="http://schemas.microsoft.com/office/powerpoint/2010/main" val="990158736"/>
+      </p:ext>
+    </p:extLst>
   </p:cSld>
   <p:clrMapOvr>
     <a:masterClrMapping/>
@@ -1880,6 +1882,7 @@
           <a:p>
             <a:fld id="{5BCAD085-E8A6-8845-BD4E-CB4CCA059FC4}" type="datetimeFigureOut">
               <a:rPr lang="en-US" smtClean="0"/>
+              <a:t>1/27/13</a:t>
             </a:fld>
             <a:endParaRPr lang="en-US"/>
           </a:p>
@@ -1921,12 +1924,18 @@
           <a:p>
             <a:fld id="{C1FF6DA9-008F-8B48-92A6-B652298478BF}" type="slidenum">
               <a:rPr lang="en-US" smtClean="0"/>
+              <a:t>‹#›</a:t>
             </a:fld>
             <a:endParaRPr lang="en-US"/>
           </a:p>
         </p:txBody>
       </p:sp>
     </p:spTree>
+    <p:extLst>
+      <p:ext uri="{BB962C8B-B14F-4D97-AF65-F5344CB8AC3E}">
+        <p14:creationId xmlns:p14="http://schemas.microsoft.com/office/powerpoint/2010/main" val="727027711"/>
+      </p:ext>
+    </p:extLst>
   </p:cSld>
   <p:clrMapOvr>
     <a:masterClrMapping/>
@@ -1968,6 +1977,7 @@
           <a:p>
             <a:fld id="{5BCAD085-E8A6-8845-BD4E-CB4CCA059FC4}" type="datetimeFigureOut">
               <a:rPr lang="en-US" smtClean="0"/>
+              <a:t>1/27/13</a:t>
             </a:fld>
             <a:endParaRPr lang="en-US"/>
           </a:p>
@@ -2009,12 +2019,18 @@
           <a:p>
             <a:fld id="{C1FF6DA9-008F-8B48-92A6-B652298478BF}" type="slidenum">
               <a:rPr lang="en-US" smtClean="0"/>
+              <a:t>‹#›</a:t>
             </a:fld>
             <a:endParaRPr lang="en-US"/>
           </a:p>
         </p:txBody>
       </p:sp>
     </p:spTree>
+    <p:extLst>
+      <p:ext uri="{BB962C8B-B14F-4D97-AF65-F5344CB8AC3E}">
+        <p14:creationId xmlns:p14="http://schemas.microsoft.com/office/powerpoint/2010/main" val="1212999818"/>
+      </p:ext>
+    </p:extLst>
   </p:cSld>
   <p:clrMapOvr>
     <a:masterClrMapping/>
@@ -2124,7 +2140,6 @@
               <a:rPr lang="en-US" smtClean="0"/>
               <a:t>Click to edit Master text styles</a:t>
             </a:r>
-            <a:endParaRPr lang="en-US" smtClean="0"/>
           </a:p>
           <a:p>
             <a:pPr lvl="1"/>
@@ -2132,7 +2147,6 @@
               <a:rPr lang="en-US" smtClean="0"/>
               <a:t>Second level</a:t>
             </a:r>
-            <a:endParaRPr lang="en-US" smtClean="0"/>
           </a:p>
           <a:p>
             <a:pPr lvl="2"/>
@@ -2140,7 +2154,6 @@
               <a:rPr lang="en-US" smtClean="0"/>
               <a:t>Third level</a:t>
             </a:r>
-            <a:endParaRPr lang="en-US" smtClean="0"/>
           </a:p>
           <a:p>
             <a:pPr lvl="3"/>
@@ -2148,7 +2161,6 @@
               <a:rPr lang="en-US" smtClean="0"/>
               <a:t>Fourth level</a:t>
             </a:r>
-            <a:endParaRPr lang="en-US" smtClean="0"/>
           </a:p>
           <a:p>
             <a:pPr lvl="4"/>
@@ -2222,7 +2234,6 @@
               <a:rPr lang="en-US" smtClean="0"/>
               <a:t>Click to edit Master text styles</a:t>
             </a:r>
-            <a:endParaRPr lang="en-US" smtClean="0"/>
           </a:p>
         </p:txBody>
       </p:sp>
@@ -2243,6 +2254,7 @@
           <a:p>
             <a:fld id="{5BCAD085-E8A6-8845-BD4E-CB4CCA059FC4}" type="datetimeFigureOut">
               <a:rPr lang="en-US" smtClean="0"/>
+              <a:t>1/27/13</a:t>
             </a:fld>
             <a:endParaRPr lang="en-US"/>
           </a:p>
@@ -2284,12 +2296,18 @@
           <a:p>
             <a:fld id="{C1FF6DA9-008F-8B48-92A6-B652298478BF}" type="slidenum">
               <a:rPr lang="en-US" smtClean="0"/>
+              <a:t>‹#›</a:t>
             </a:fld>
             <a:endParaRPr lang="en-US"/>
           </a:p>
         </p:txBody>
       </p:sp>
     </p:spTree>
+    <p:extLst>
+      <p:ext uri="{BB962C8B-B14F-4D97-AF65-F5344CB8AC3E}">
+        <p14:creationId xmlns:p14="http://schemas.microsoft.com/office/powerpoint/2010/main" val="1840726560"/>
+      </p:ext>
+    </p:extLst>
   </p:cSld>
   <p:clrMapOvr>
     <a:masterClrMapping/>
@@ -2469,7 +2487,6 @@
               <a:rPr lang="en-US" smtClean="0"/>
               <a:t>Click to edit Master text styles</a:t>
             </a:r>
-            <a:endParaRPr lang="en-US" smtClean="0"/>
           </a:p>
         </p:txBody>
       </p:sp>
@@ -2490,6 +2507,7 @@
           <a:p>
             <a:fld id="{5BCAD085-E8A6-8845-BD4E-CB4CCA059FC4}" type="datetimeFigureOut">
               <a:rPr lang="en-US" smtClean="0"/>
+              <a:t>1/27/13</a:t>
             </a:fld>
             <a:endParaRPr lang="en-US"/>
           </a:p>
@@ -2531,12 +2549,18 @@
           <a:p>
             <a:fld id="{C1FF6DA9-008F-8B48-92A6-B652298478BF}" type="slidenum">
               <a:rPr lang="en-US" smtClean="0"/>
+              <a:t>‹#›</a:t>
             </a:fld>
             <a:endParaRPr lang="en-US"/>
           </a:p>
         </p:txBody>
       </p:sp>
     </p:spTree>
+    <p:extLst>
+      <p:ext uri="{BB962C8B-B14F-4D97-AF65-F5344CB8AC3E}">
+        <p14:creationId xmlns:p14="http://schemas.microsoft.com/office/powerpoint/2010/main" val="3889236939"/>
+      </p:ext>
+    </p:extLst>
   </p:cSld>
   <p:clrMapOvr>
     <a:masterClrMapping/>
@@ -2629,7 +2653,6 @@
               <a:rPr lang="en-US" smtClean="0"/>
               <a:t>Click to edit Master text styles</a:t>
             </a:r>
-            <a:endParaRPr lang="en-US" smtClean="0"/>
           </a:p>
           <a:p>
             <a:pPr lvl="1"/>
@@ -2637,7 +2660,6 @@
               <a:rPr lang="en-US" smtClean="0"/>
               <a:t>Second level</a:t>
             </a:r>
-            <a:endParaRPr lang="en-US" smtClean="0"/>
           </a:p>
           <a:p>
             <a:pPr lvl="2"/>
@@ -2645,7 +2667,6 @@
               <a:rPr lang="en-US" smtClean="0"/>
               <a:t>Third level</a:t>
             </a:r>
-            <a:endParaRPr lang="en-US" smtClean="0"/>
           </a:p>
           <a:p>
             <a:pPr lvl="3"/>
@@ -2653,7 +2674,6 @@
               <a:rPr lang="en-US" smtClean="0"/>
               <a:t>Fourth level</a:t>
             </a:r>
-            <a:endParaRPr lang="en-US" smtClean="0"/>
           </a:p>
           <a:p>
             <a:pPr lvl="4"/>
@@ -2700,6 +2720,7 @@
           <a:p>
             <a:fld id="{5BCAD085-E8A6-8845-BD4E-CB4CCA059FC4}" type="datetimeFigureOut">
               <a:rPr lang="en-US" smtClean="0"/>
+              <a:t>1/27/13</a:t>
             </a:fld>
             <a:endParaRPr lang="en-US"/>
           </a:p>
@@ -2777,12 +2798,18 @@
           <a:p>
             <a:fld id="{C1FF6DA9-008F-8B48-92A6-B652298478BF}" type="slidenum">
               <a:rPr lang="en-US" smtClean="0"/>
+              <a:t>‹#›</a:t>
             </a:fld>
             <a:endParaRPr lang="en-US"/>
           </a:p>
         </p:txBody>
       </p:sp>
     </p:spTree>
+    <p:extLst>
+      <p:ext uri="{BB962C8B-B14F-4D97-AF65-F5344CB8AC3E}">
+        <p14:creationId xmlns:p14="http://schemas.microsoft.com/office/powerpoint/2010/main" val="2209977519"/>
+      </p:ext>
+    </p:extLst>
   </p:cSld>
   <p:clrMap bg1="lt1" tx1="dk1" bg2="lt2" tx2="dk2" accent1="accent1" accent2="accent2" accent3="accent3" accent4="accent4" accent5="accent5" accent6="accent6" hlink="hlink" folHlink="folHlink"/>
   <p:sldLayoutIdLst>
@@ -2820,7 +2847,7 @@
         <a:spcBef>
           <a:spcPct val="20000"/>
         </a:spcBef>
-        <a:buFont typeface="Arial" panose="020B0604020202020204"/>
+        <a:buFont typeface="Arial"/>
         <a:buChar char="•"/>
         <a:defRPr sz="3200" kern="1200">
           <a:solidFill>
@@ -2835,7 +2862,7 @@
         <a:spcBef>
           <a:spcPct val="20000"/>
         </a:spcBef>
-        <a:buFont typeface="Arial" panose="020B0604020202020204"/>
+        <a:buFont typeface="Arial"/>
         <a:buChar char="–"/>
         <a:defRPr sz="2800" kern="1200">
           <a:solidFill>
@@ -2850,7 +2877,7 @@
         <a:spcBef>
           <a:spcPct val="20000"/>
         </a:spcBef>
-        <a:buFont typeface="Arial" panose="020B0604020202020204"/>
+        <a:buFont typeface="Arial"/>
         <a:buChar char="•"/>
         <a:defRPr sz="2400" kern="1200">
           <a:solidFill>
@@ -2865,7 +2892,7 @@
         <a:spcBef>
           <a:spcPct val="20000"/>
         </a:spcBef>
-        <a:buFont typeface="Arial" panose="020B0604020202020204"/>
+        <a:buFont typeface="Arial"/>
         <a:buChar char="–"/>
         <a:defRPr sz="2000" kern="1200">
           <a:solidFill>
@@ -2880,7 +2907,7 @@
         <a:spcBef>
           <a:spcPct val="20000"/>
         </a:spcBef>
-        <a:buFont typeface="Arial" panose="020B0604020202020204"/>
+        <a:buFont typeface="Arial"/>
         <a:buChar char="»"/>
         <a:defRPr sz="2000" kern="1200">
           <a:solidFill>
@@ -2895,7 +2922,7 @@
         <a:spcBef>
           <a:spcPct val="20000"/>
         </a:spcBef>
-        <a:buFont typeface="Arial" panose="020B0604020202020204"/>
+        <a:buFont typeface="Arial"/>
         <a:buChar char="•"/>
         <a:defRPr sz="2000" kern="1200">
           <a:solidFill>
@@ -2910,7 +2937,7 @@
         <a:spcBef>
           <a:spcPct val="20000"/>
         </a:spcBef>
-        <a:buFont typeface="Arial" panose="020B0604020202020204"/>
+        <a:buFont typeface="Arial"/>
         <a:buChar char="•"/>
         <a:defRPr sz="2000" kern="1200">
           <a:solidFill>
@@ -2925,7 +2952,7 @@
         <a:spcBef>
           <a:spcPct val="20000"/>
         </a:spcBef>
-        <a:buFont typeface="Arial" panose="020B0604020202020204"/>
+        <a:buFont typeface="Arial"/>
         <a:buChar char="•"/>
         <a:defRPr sz="2000" kern="1200">
           <a:solidFill>
@@ -2940,7 +2967,7 @@
         <a:spcBef>
           <a:spcPct val="20000"/>
         </a:spcBef>
-        <a:buFont typeface="Arial" panose="020B0604020202020204"/>
+        <a:buFont typeface="Arial"/>
         <a:buChar char="•"/>
         <a:defRPr sz="2000" kern="1200">
           <a:solidFill>
@@ -3052,8 +3079,24 @@
 </file>
 
 <file path=ppt/slides/slide1.xml><?xml version="1.0" encoding="utf-8"?>
-<p:sld xmlns:a="http://schemas.openxmlformats.org/drawingml/2006/main" xmlns:r="http://schemas.openxmlformats.org/officeDocument/2006/relationships" xmlns:p="http://schemas.openxmlformats.org/presentationml/2006/main">
+<p:sld xmlns:a="http://schemas.openxmlformats.org/drawingml/2006/main" xmlns:p="http://schemas.openxmlformats.org/presentationml/2006/main" xmlns:r="http://schemas.openxmlformats.org/officeDocument/2006/relationships">
   <p:cSld>
+    <p:bg>
+      <p:bgPr>
+        <a:gradFill rotWithShape="1">
+          <a:gsLst>
+            <a:gs pos="0">
+              <a:srgbClr val="F6F8FC"/>
+            </a:gs>
+            <a:gs pos="100000">
+              <a:srgbClr val="E6EDF5"/>
+            </a:gs>
+          </a:gsLst>
+          <a:lin scaled="0"/>
+        </a:gradFill>
+        <a:effectLst/>
+      </p:bgPr>
+    </p:bg>
     <p:spTree>
       <p:nvGrpSpPr>
         <p:cNvPr id="1" name=""/>
@@ -3061,215 +3104,89 @@
         <p:nvPr/>
       </p:nvGrpSpPr>
       <p:grpSpPr/>
-      <p:pic>
-        <p:nvPicPr>
-          <p:cNvPr id="3" name="Picture 2" descr="雷达mid360.png"/>
-          <p:cNvPicPr>
-            <a:picLocks noChangeAspect="1"/>
-          </p:cNvPicPr>
+      <p:sp>
+        <p:nvSpPr>
+          <p:cNvPr id="2" name="Rounded Rectangle 1"/>
+          <p:cNvSpPr/>
           <p:nvPr/>
-        </p:nvPicPr>
-        <p:blipFill>
-          <a:blip r:embed="rId1"/>
-          <a:stretch>
-            <a:fillRect/>
-          </a:stretch>
-        </p:blipFill>
+        </p:nvSpPr>
         <p:spPr>
           <a:xfrm>
-            <a:off x="3474720" y="274320"/>
-            <a:ext cx="822960" cy="619699"/>
+            <a:off x="411480" y="411480"/>
+            <a:ext cx="1920240" cy="3291840"/>
           </a:xfrm>
-          <a:prstGeom prst="rect">
-            <a:avLst/>
+          <a:prstGeom prst="roundRect">
+            <a:avLst>
+              <a:gd name="adj" fmla="val 4000"/>
+            </a:avLst>
           </a:prstGeom>
-          <a:ln w="12700">
-            <a:solidFill>
-              <a:srgbClr val="4472C4"/>
-            </a:solidFill>
-            <a:prstDash val="dash"/>
+          <a:solidFill>
+            <a:srgbClr val="4472C4"/>
+          </a:solidFill>
+          <a:ln>
+            <a:noFill/>
           </a:ln>
+          <a:effectLst>
+            <a:outerShdw blurRad="38100" dist="25400" dir="2700000" algn="tl" rotWithShape="0">
+              <a:srgbClr val="666666">
+                <a:alpha val="28000"/>
+              </a:srgbClr>
+            </a:outerShdw>
+          </a:effectLst>
         </p:spPr>
-      </p:pic>
-      <p:sp>
-        <p:nvSpPr>
-          <p:cNvPr id="4" name="TextBox 3"/>
-          <p:cNvSpPr txBox="1"/>
+        <p:style>
+          <a:lnRef idx="1">
+            <a:schemeClr val="accent1"/>
+          </a:lnRef>
+          <a:fillRef idx="3">
+            <a:schemeClr val="accent1"/>
+          </a:fillRef>
+          <a:effectRef idx="2">
+            <a:schemeClr val="accent1"/>
+          </a:effectRef>
+          <a:fontRef idx="minor">
+            <a:schemeClr val="lt1"/>
+          </a:fontRef>
+        </p:style>
+        <p:txBody>
+          <a:bodyPr rtlCol="0" anchor="t" wrap="square" lIns="20000" rIns="20000" tIns="5000" bIns="5000"/>
+          <a:lstStyle/>
+          <a:p>
+            <a:pPr algn="ctr"/>
+            <a:r>
+              <a:rPr sz="1100" b="1">
+                <a:solidFill>
+                  <a:srgbClr val="FFFFFF"/>
+                </a:solidFill>
+                <a:latin typeface="Times New Roman"/>
+              </a:rPr>
+              <a:t>UGV Platform</a:t>
+            </a:r>
+          </a:p>
+        </p:txBody>
+      </p:sp>
+      <p:sp>
+        <p:nvSpPr>
+          <p:cNvPr id="3" name="Rounded Rectangle 2"/>
+          <p:cNvSpPr/>
           <p:nvPr/>
         </p:nvSpPr>
         <p:spPr>
           <a:xfrm>
-            <a:off x="2926080" y="939739"/>
-            <a:ext cx="1920240" cy="365760"/>
+            <a:off x="441480" y="740664"/>
+            <a:ext cx="1860240" cy="2932656"/>
           </a:xfrm>
-          <a:prstGeom prst="rect">
-            <a:avLst/>
-          </a:prstGeom>
-          <a:noFill/>
-        </p:spPr>
-        <p:txBody>
-          <a:bodyPr wrap="square">
-            <a:spAutoFit/>
-          </a:bodyPr>
-          <a:lstStyle/>
-          <a:p>
-            <a:pPr algn="ctr">
-              <a:defRPr sz="800" b="1">
-                <a:latin typeface="Arial" panose="020B0604020202020204"/>
-              </a:defRPr>
-            </a:pPr>
-            <a:r>
-              <a:t>(a) Livox Mid-360 LiDAR</a:t>
-            </a:r>
-          </a:p>
-        </p:txBody>
-      </p:sp>
-      <p:pic>
-        <p:nvPicPr>
-          <p:cNvPr id="5" name="Picture 4" descr="工控机.png"/>
-          <p:cNvPicPr>
-            <a:picLocks noChangeAspect="1"/>
-          </p:cNvPicPr>
-          <p:nvPr/>
-        </p:nvPicPr>
-        <p:blipFill>
-          <a:blip r:embed="rId2"/>
-          <a:stretch>
-            <a:fillRect/>
-          </a:stretch>
-        </p:blipFill>
-        <p:spPr>
-          <a:xfrm>
-            <a:off x="3474720" y="1554480"/>
-            <a:ext cx="822960" cy="619699"/>
-          </a:xfrm>
-          <a:prstGeom prst="rect">
-            <a:avLst/>
-          </a:prstGeom>
-          <a:ln w="12700">
-            <a:solidFill>
-              <a:srgbClr val="4472C4"/>
-            </a:solidFill>
-            <a:prstDash val="dash"/>
-          </a:ln>
-        </p:spPr>
-      </p:pic>
-      <p:sp>
-        <p:nvSpPr>
-          <p:cNvPr id="6" name="TextBox 5"/>
-          <p:cNvSpPr txBox="1"/>
-          <p:nvPr/>
-        </p:nvSpPr>
-        <p:spPr>
-          <a:xfrm>
-            <a:off x="2926080" y="2219899"/>
-            <a:ext cx="1920240" cy="365760"/>
-          </a:xfrm>
-          <a:prstGeom prst="rect">
-            <a:avLst/>
-          </a:prstGeom>
-          <a:noFill/>
-        </p:spPr>
-        <p:txBody>
-          <a:bodyPr wrap="square">
-            <a:spAutoFit/>
-          </a:bodyPr>
-          <a:lstStyle/>
-          <a:p>
-            <a:pPr algn="ctr">
-              <a:defRPr sz="800" b="1">
-                <a:latin typeface="Arial" panose="020B0604020202020204"/>
-              </a:defRPr>
-            </a:pPr>
-            <a:r>
-              <a:t>(b) Jetson AGX Orin</a:t>
-            </a:r>
-          </a:p>
-        </p:txBody>
-      </p:sp>
-      <p:pic>
-        <p:nvPicPr>
-          <p:cNvPr id="7" name="Picture 6" descr="无人小车底盘.png"/>
-          <p:cNvPicPr>
-            <a:picLocks noChangeAspect="1"/>
-          </p:cNvPicPr>
-          <p:nvPr/>
-        </p:nvPicPr>
-        <p:blipFill>
-          <a:blip r:embed="rId3"/>
-          <a:stretch>
-            <a:fillRect/>
-          </a:stretch>
-        </p:blipFill>
-        <p:spPr>
-          <a:xfrm>
-            <a:off x="3474720" y="2834640"/>
-            <a:ext cx="822960" cy="437523"/>
-          </a:xfrm>
-          <a:prstGeom prst="rect">
-            <a:avLst/>
-          </a:prstGeom>
-          <a:ln w="12700">
-            <a:solidFill>
-              <a:srgbClr val="4472C4"/>
-            </a:solidFill>
-            <a:prstDash val="dash"/>
-          </a:ln>
-        </p:spPr>
-      </p:pic>
-      <p:sp>
-        <p:nvSpPr>
-          <p:cNvPr id="8" name="TextBox 7"/>
-          <p:cNvSpPr txBox="1"/>
-          <p:nvPr/>
-        </p:nvSpPr>
-        <p:spPr>
-          <a:xfrm>
-            <a:off x="2926080" y="3317883"/>
-            <a:ext cx="1920240" cy="365760"/>
-          </a:xfrm>
-          <a:prstGeom prst="rect">
-            <a:avLst/>
-          </a:prstGeom>
-          <a:noFill/>
-        </p:spPr>
-        <p:txBody>
-          <a:bodyPr wrap="square">
-            <a:spAutoFit/>
-          </a:bodyPr>
-          <a:lstStyle/>
-          <a:p>
-            <a:pPr algn="ctr">
-              <a:defRPr sz="800" b="1">
-                <a:latin typeface="Arial" panose="020B0604020202020204"/>
-              </a:defRPr>
-            </a:pPr>
-            <a:r>
-              <a:t>(c) Ackermann chassis</a:t>
-            </a:r>
-          </a:p>
-        </p:txBody>
-      </p:sp>
-      <p:sp>
-        <p:nvSpPr>
-          <p:cNvPr id="9" name="Right Arrow 8"/>
-          <p:cNvSpPr/>
-          <p:nvPr/>
-        </p:nvSpPr>
-        <p:spPr>
-          <a:xfrm>
-            <a:off x="2011680" y="822960"/>
-            <a:ext cx="1188720" cy="73152"/>
-          </a:xfrm>
-          <a:prstGeom prst="rightArrow">
-            <a:avLst/>
+          <a:prstGeom prst="roundRect">
+            <a:avLst>
+              <a:gd name="adj" fmla="val 2000"/>
+            </a:avLst>
           </a:prstGeom>
           <a:solidFill>
-            <a:srgbClr val="0072C6"/>
+            <a:srgbClr val="FFFFFF"/>
           </a:solidFill>
-          <a:ln>
+          <a:ln w="9525">
             <a:solidFill>
-              <a:srgbClr val="0072C6"/>
+              <a:srgbClr val="D6E4F0"/>
             </a:solidFill>
           </a:ln>
         </p:spPr>
@@ -3295,26 +3212,125 @@
           </a:p>
         </p:txBody>
       </p:sp>
-      <p:sp>
-        <p:nvSpPr>
-          <p:cNvPr id="10" name="Right Arrow 9"/>
+      <p:pic>
+        <p:nvPicPr>
+          <p:cNvPr id="4" name="Picture 3" descr="shape_9_图片 11.png"/>
+          <p:cNvPicPr>
+            <a:picLocks noChangeAspect="1"/>
+          </p:cNvPicPr>
+          <p:nvPr/>
+        </p:nvPicPr>
+        <p:blipFill>
+          <a:blip r:embed="rId2"/>
+          <a:stretch>
+            <a:fillRect/>
+          </a:stretch>
+        </p:blipFill>
+        <p:spPr>
+          <a:xfrm>
+            <a:off x="453480" y="752664"/>
+            <a:ext cx="1836240" cy="2908656"/>
+          </a:xfrm>
+          <a:prstGeom prst="rect">
+            <a:avLst/>
+          </a:prstGeom>
+        </p:spPr>
+      </p:pic>
+      <p:sp>
+        <p:nvSpPr>
+          <p:cNvPr id="5" name="Rounded Rectangle 4"/>
           <p:cNvSpPr/>
           <p:nvPr/>
         </p:nvSpPr>
         <p:spPr>
           <a:xfrm>
-            <a:off x="1463040" y="2011680"/>
-            <a:ext cx="1737360" cy="73152"/>
+            <a:off x="3017520" y="411480"/>
+            <a:ext cx="2880360" cy="987552"/>
           </a:xfrm>
-          <a:prstGeom prst="rightArrow">
-            <a:avLst/>
+          <a:prstGeom prst="roundRect">
+            <a:avLst>
+              <a:gd name="adj" fmla="val 6000"/>
+            </a:avLst>
           </a:prstGeom>
           <a:solidFill>
-            <a:srgbClr val="0072C6"/>
+            <a:srgbClr val="4472C4"/>
           </a:solidFill>
           <a:ln>
+            <a:noFill/>
+          </a:ln>
+          <a:effectLst>
+            <a:outerShdw blurRad="38100" dist="25400" dir="2700000" algn="tl" rotWithShape="0">
+              <a:srgbClr val="666666">
+                <a:alpha val="28000"/>
+              </a:srgbClr>
+            </a:outerShdw>
+          </a:effectLst>
+        </p:spPr>
+        <p:style>
+          <a:lnRef idx="1">
+            <a:schemeClr val="accent1"/>
+          </a:lnRef>
+          <a:fillRef idx="3">
+            <a:schemeClr val="accent1"/>
+          </a:fillRef>
+          <a:effectRef idx="2">
+            <a:schemeClr val="accent1"/>
+          </a:effectRef>
+          <a:fontRef idx="minor">
+            <a:schemeClr val="lt1"/>
+          </a:fontRef>
+        </p:style>
+        <p:txBody>
+          <a:bodyPr rtlCol="0" anchor="t" wrap="square" lIns="20000" rIns="20000" tIns="5000" bIns="5000"/>
+          <a:lstStyle/>
+          <a:p>
+            <a:pPr algn="ctr"/>
+            <a:r>
+              <a:rPr sz="900" b="1">
+                <a:solidFill>
+                  <a:srgbClr val="FFFFFF"/>
+                </a:solidFill>
+                <a:latin typeface="Times New Roman"/>
+              </a:rPr>
+              <a:t>(a) Livox Mid-360 LiDAR</a:t>
+            </a:r>
+          </a:p>
+          <a:p>
+            <a:pPr algn="ctr"/>
+            <a:r>
+              <a:rPr sz="700" b="0">
+                <a:solidFill>
+                  <a:srgbClr val="D0DDF0"/>
+                </a:solidFill>
+                <a:latin typeface="Times New Roman"/>
+              </a:rPr>
+              <a:t>3D Point Cloud Sensing</a:t>
+            </a:r>
+          </a:p>
+        </p:txBody>
+      </p:sp>
+      <p:sp>
+        <p:nvSpPr>
+          <p:cNvPr id="6" name="Rounded Rectangle 5"/>
+          <p:cNvSpPr/>
+          <p:nvPr/>
+        </p:nvSpPr>
+        <p:spPr>
+          <a:xfrm>
+            <a:off x="3042520" y="786749"/>
+            <a:ext cx="2830360" cy="587283"/>
+          </a:xfrm>
+          <a:prstGeom prst="roundRect">
+            <a:avLst>
+              <a:gd name="adj" fmla="val 3000"/>
+            </a:avLst>
+          </a:prstGeom>
+          <a:solidFill>
+            <a:srgbClr val="FFFFFF"/>
+          </a:solidFill>
+          <a:ln w="6350">
             <a:solidFill>
-              <a:srgbClr val="0072C6"/>
+              <a:srgbClr val="D6E4F0"/>
             </a:solidFill>
           </a:ln>
         </p:spPr>
@@ -3340,26 +3356,125 @@
           </a:p>
         </p:txBody>
       </p:sp>
-      <p:sp>
-        <p:nvSpPr>
-          <p:cNvPr id="11" name="Right Arrow 10"/>
+      <p:pic>
+        <p:nvPicPr>
+          <p:cNvPr id="7" name="Picture 6" descr="shape_0_Picture 2.png"/>
+          <p:cNvPicPr>
+            <a:picLocks noChangeAspect="1"/>
+          </p:cNvPicPr>
+          <p:nvPr/>
+        </p:nvPicPr>
+        <p:blipFill>
+          <a:blip r:embed="rId3"/>
+          <a:stretch>
+            <a:fillRect/>
+          </a:stretch>
+        </p:blipFill>
+        <p:spPr>
+          <a:xfrm>
+            <a:off x="3679351" y="794749"/>
+            <a:ext cx="1556698" cy="571283"/>
+          </a:xfrm>
+          <a:prstGeom prst="rect">
+            <a:avLst/>
+          </a:prstGeom>
+        </p:spPr>
+      </p:pic>
+      <p:sp>
+        <p:nvSpPr>
+          <p:cNvPr id="8" name="Rounded Rectangle 7"/>
           <p:cNvSpPr/>
           <p:nvPr/>
         </p:nvSpPr>
         <p:spPr>
           <a:xfrm>
-            <a:off x="2011680" y="3108960"/>
-            <a:ext cx="1188720" cy="73152"/>
+            <a:off x="3017520" y="1563624"/>
+            <a:ext cx="2880360" cy="987552"/>
           </a:xfrm>
-          <a:prstGeom prst="rightArrow">
-            <a:avLst/>
+          <a:prstGeom prst="roundRect">
+            <a:avLst>
+              <a:gd name="adj" fmla="val 6000"/>
+            </a:avLst>
           </a:prstGeom>
           <a:solidFill>
-            <a:srgbClr val="0072C6"/>
+            <a:srgbClr val="4472C4"/>
           </a:solidFill>
           <a:ln>
+            <a:noFill/>
+          </a:ln>
+          <a:effectLst>
+            <a:outerShdw blurRad="38100" dist="25400" dir="2700000" algn="tl" rotWithShape="0">
+              <a:srgbClr val="666666">
+                <a:alpha val="28000"/>
+              </a:srgbClr>
+            </a:outerShdw>
+          </a:effectLst>
+        </p:spPr>
+        <p:style>
+          <a:lnRef idx="1">
+            <a:schemeClr val="accent1"/>
+          </a:lnRef>
+          <a:fillRef idx="3">
+            <a:schemeClr val="accent1"/>
+          </a:fillRef>
+          <a:effectRef idx="2">
+            <a:schemeClr val="accent1"/>
+          </a:effectRef>
+          <a:fontRef idx="minor">
+            <a:schemeClr val="lt1"/>
+          </a:fontRef>
+        </p:style>
+        <p:txBody>
+          <a:bodyPr rtlCol="0" anchor="t" wrap="square" lIns="20000" rIns="20000" tIns="5000" bIns="5000"/>
+          <a:lstStyle/>
+          <a:p>
+            <a:pPr algn="ctr"/>
+            <a:r>
+              <a:rPr sz="900" b="1">
+                <a:solidFill>
+                  <a:srgbClr val="FFFFFF"/>
+                </a:solidFill>
+                <a:latin typeface="Times New Roman"/>
+              </a:rPr>
+              <a:t>(b) Jetson AGX Orin</a:t>
+            </a:r>
+          </a:p>
+          <a:p>
+            <a:pPr algn="ctr"/>
+            <a:r>
+              <a:rPr sz="700" b="0">
+                <a:solidFill>
+                  <a:srgbClr val="D0DDF0"/>
+                </a:solidFill>
+                <a:latin typeface="Times New Roman"/>
+              </a:rPr>
+              <a:t>Onboard AI Computing</a:t>
+            </a:r>
+          </a:p>
+        </p:txBody>
+      </p:sp>
+      <p:sp>
+        <p:nvSpPr>
+          <p:cNvPr id="9" name="Rounded Rectangle 8"/>
+          <p:cNvSpPr/>
+          <p:nvPr/>
+        </p:nvSpPr>
+        <p:spPr>
+          <a:xfrm>
+            <a:off x="3042520" y="1938893"/>
+            <a:ext cx="2830360" cy="587283"/>
+          </a:xfrm>
+          <a:prstGeom prst="roundRect">
+            <a:avLst>
+              <a:gd name="adj" fmla="val 3000"/>
+            </a:avLst>
+          </a:prstGeom>
+          <a:solidFill>
+            <a:srgbClr val="FFFFFF"/>
+          </a:solidFill>
+          <a:ln w="6350">
             <a:solidFill>
-              <a:srgbClr val="0072C6"/>
+              <a:srgbClr val="D6E4F0"/>
             </a:solidFill>
           </a:ln>
         </p:spPr>
@@ -3387,7 +3502,7 @@
       </p:sp>
       <p:pic>
         <p:nvPicPr>
-          <p:cNvPr id="12" name="图片 11" descr="fig_platform_robot"/>
+          <p:cNvPr id="10" name="Picture 9" descr="shape_2_Picture 4.png"/>
           <p:cNvPicPr>
             <a:picLocks noChangeAspect="1"/>
           </p:cNvPicPr>
@@ -3401,14 +3516,395 @@
         </p:blipFill>
         <p:spPr>
           <a:xfrm>
-            <a:off x="305435" y="91440"/>
-            <a:ext cx="2314575" cy="4114800"/>
+            <a:off x="3679351" y="1946893"/>
+            <a:ext cx="1556698" cy="571283"/>
           </a:xfrm>
           <a:prstGeom prst="rect">
             <a:avLst/>
           </a:prstGeom>
         </p:spPr>
       </p:pic>
+      <p:sp>
+        <p:nvSpPr>
+          <p:cNvPr id="11" name="Rounded Rectangle 10"/>
+          <p:cNvSpPr/>
+          <p:nvPr/>
+        </p:nvSpPr>
+        <p:spPr>
+          <a:xfrm>
+            <a:off x="3017520" y="2715768"/>
+            <a:ext cx="2880360" cy="987552"/>
+          </a:xfrm>
+          <a:prstGeom prst="roundRect">
+            <a:avLst>
+              <a:gd name="adj" fmla="val 6000"/>
+            </a:avLst>
+          </a:prstGeom>
+          <a:solidFill>
+            <a:srgbClr val="4472C4"/>
+          </a:solidFill>
+          <a:ln>
+            <a:noFill/>
+          </a:ln>
+          <a:effectLst>
+            <a:outerShdw blurRad="38100" dist="25400" dir="2700000" algn="tl" rotWithShape="0">
+              <a:srgbClr val="666666">
+                <a:alpha val="28000"/>
+              </a:srgbClr>
+            </a:outerShdw>
+          </a:effectLst>
+        </p:spPr>
+        <p:style>
+          <a:lnRef idx="1">
+            <a:schemeClr val="accent1"/>
+          </a:lnRef>
+          <a:fillRef idx="3">
+            <a:schemeClr val="accent1"/>
+          </a:fillRef>
+          <a:effectRef idx="2">
+            <a:schemeClr val="accent1"/>
+          </a:effectRef>
+          <a:fontRef idx="minor">
+            <a:schemeClr val="lt1"/>
+          </a:fontRef>
+        </p:style>
+        <p:txBody>
+          <a:bodyPr rtlCol="0" anchor="t" wrap="square" lIns="20000" rIns="20000" tIns="5000" bIns="5000"/>
+          <a:lstStyle/>
+          <a:p>
+            <a:pPr algn="ctr"/>
+            <a:r>
+              <a:rPr sz="900" b="1">
+                <a:solidFill>
+                  <a:srgbClr val="FFFFFF"/>
+                </a:solidFill>
+                <a:latin typeface="Times New Roman"/>
+              </a:rPr>
+              <a:t>(c) Ackermann Chassis</a:t>
+            </a:r>
+          </a:p>
+          <a:p>
+            <a:pPr algn="ctr"/>
+            <a:r>
+              <a:rPr sz="700" b="0">
+                <a:solidFill>
+                  <a:srgbClr val="D0DDF0"/>
+                </a:solidFill>
+                <a:latin typeface="Times New Roman"/>
+              </a:rPr>
+              <a:t>Bicycle Kinematic Model</a:t>
+            </a:r>
+          </a:p>
+        </p:txBody>
+      </p:sp>
+      <p:sp>
+        <p:nvSpPr>
+          <p:cNvPr id="12" name="Rounded Rectangle 11"/>
+          <p:cNvSpPr/>
+          <p:nvPr/>
+        </p:nvSpPr>
+        <p:spPr>
+          <a:xfrm>
+            <a:off x="3042520" y="3091037"/>
+            <a:ext cx="2830360" cy="587283"/>
+          </a:xfrm>
+          <a:prstGeom prst="roundRect">
+            <a:avLst>
+              <a:gd name="adj" fmla="val 3000"/>
+            </a:avLst>
+          </a:prstGeom>
+          <a:solidFill>
+            <a:srgbClr val="FFFFFF"/>
+          </a:solidFill>
+          <a:ln w="6350">
+            <a:solidFill>
+              <a:srgbClr val="D6E4F0"/>
+            </a:solidFill>
+          </a:ln>
+        </p:spPr>
+        <p:style>
+          <a:lnRef idx="1">
+            <a:schemeClr val="accent1"/>
+          </a:lnRef>
+          <a:fillRef idx="3">
+            <a:schemeClr val="accent1"/>
+          </a:fillRef>
+          <a:effectRef idx="2">
+            <a:schemeClr val="accent1"/>
+          </a:effectRef>
+          <a:fontRef idx="minor">
+            <a:schemeClr val="lt1"/>
+          </a:fontRef>
+        </p:style>
+        <p:txBody>
+          <a:bodyPr rtlCol="0" anchor="ctr"/>
+          <a:lstStyle/>
+          <a:p>
+            <a:pPr algn="ctr"/>
+          </a:p>
+        </p:txBody>
+      </p:sp>
+      <p:pic>
+        <p:nvPicPr>
+          <p:cNvPr id="13" name="Picture 12" descr="shape_4_Picture 6.png"/>
+          <p:cNvPicPr>
+            <a:picLocks noChangeAspect="1"/>
+          </p:cNvPicPr>
+          <p:nvPr/>
+        </p:nvPicPr>
+        <p:blipFill>
+          <a:blip r:embed="rId5"/>
+          <a:stretch>
+            <a:fillRect/>
+          </a:stretch>
+        </p:blipFill>
+        <p:spPr>
+          <a:xfrm>
+            <a:off x="3679351" y="3099037"/>
+            <a:ext cx="1556698" cy="571283"/>
+          </a:xfrm>
+          <a:prstGeom prst="rect">
+            <a:avLst/>
+          </a:prstGeom>
+        </p:spPr>
+      </p:pic>
+      <p:sp>
+        <p:nvSpPr>
+          <p:cNvPr id="14" name="Oval 13"/>
+          <p:cNvSpPr/>
+          <p:nvPr/>
+        </p:nvSpPr>
+        <p:spPr>
+          <a:xfrm>
+            <a:off x="2321720" y="950120"/>
+            <a:ext cx="20000" cy="20000"/>
+          </a:xfrm>
+          <a:prstGeom prst="ellipse">
+            <a:avLst/>
+          </a:prstGeom>
+          <a:solidFill>
+            <a:srgbClr val="4472C4"/>
+          </a:solidFill>
+          <a:ln>
+            <a:noFill/>
+          </a:ln>
+        </p:spPr>
+        <p:style>
+          <a:lnRef idx="1">
+            <a:schemeClr val="accent1"/>
+          </a:lnRef>
+          <a:fillRef idx="3">
+            <a:schemeClr val="accent1"/>
+          </a:fillRef>
+          <a:effectRef idx="2">
+            <a:schemeClr val="accent1"/>
+          </a:effectRef>
+          <a:fontRef idx="minor">
+            <a:schemeClr val="lt1"/>
+          </a:fontRef>
+        </p:style>
+        <p:txBody>
+          <a:bodyPr rtlCol="0" anchor="ctr"/>
+          <a:lstStyle/>
+          <a:p>
+            <a:pPr algn="ctr"/>
+          </a:p>
+        </p:txBody>
+      </p:sp>
+      <p:cxnSp>
+        <p:nvCxnSpPr>
+          <p:cNvPr id="15" name="Connector 14"/>
+          <p:cNvCxnSpPr/>
+          <p:nvPr/>
+        </p:nvCxnSpPr>
+        <p:spPr>
+          <a:xfrm flipV="1">
+            <a:off x="2341720" y="905256"/>
+            <a:ext cx="675800" cy="54864"/>
+          </a:xfrm>
+          <a:prstGeom prst="line">
+            <a:avLst/>
+          </a:prstGeom>
+          <a:ln w="19050">
+            <a:solidFill>
+              <a:srgbClr val="4472C4"/>
+            </a:solidFill>
+            <a:tailEnd type="triangle" w="lg" len="lg"/>
+          </a:ln>
+        </p:spPr>
+        <p:style>
+          <a:lnRef idx="2">
+            <a:schemeClr val="accent1"/>
+          </a:lnRef>
+          <a:fillRef idx="0">
+            <a:schemeClr val="accent1"/>
+          </a:fillRef>
+          <a:effectRef idx="1">
+            <a:schemeClr val="accent1"/>
+          </a:effectRef>
+          <a:fontRef idx="minor">
+            <a:schemeClr val="tx1"/>
+          </a:fontRef>
+        </p:style>
+      </p:cxnSp>
+      <p:sp>
+        <p:nvSpPr>
+          <p:cNvPr id="16" name="Oval 15"/>
+          <p:cNvSpPr/>
+          <p:nvPr/>
+        </p:nvSpPr>
+        <p:spPr>
+          <a:xfrm>
+            <a:off x="2321720" y="2047400"/>
+            <a:ext cx="20000" cy="20000"/>
+          </a:xfrm>
+          <a:prstGeom prst="ellipse">
+            <a:avLst/>
+          </a:prstGeom>
+          <a:solidFill>
+            <a:srgbClr val="4472C4"/>
+          </a:solidFill>
+          <a:ln>
+            <a:noFill/>
+          </a:ln>
+        </p:spPr>
+        <p:style>
+          <a:lnRef idx="1">
+            <a:schemeClr val="accent1"/>
+          </a:lnRef>
+          <a:fillRef idx="3">
+            <a:schemeClr val="accent1"/>
+          </a:fillRef>
+          <a:effectRef idx="2">
+            <a:schemeClr val="accent1"/>
+          </a:effectRef>
+          <a:fontRef idx="minor">
+            <a:schemeClr val="lt1"/>
+          </a:fontRef>
+        </p:style>
+        <p:txBody>
+          <a:bodyPr rtlCol="0" anchor="ctr"/>
+          <a:lstStyle/>
+          <a:p>
+            <a:pPr algn="ctr"/>
+          </a:p>
+        </p:txBody>
+      </p:sp>
+      <p:cxnSp>
+        <p:nvCxnSpPr>
+          <p:cNvPr id="17" name="Connector 16"/>
+          <p:cNvCxnSpPr/>
+          <p:nvPr/>
+        </p:nvCxnSpPr>
+        <p:spPr>
+          <a:xfrm>
+            <a:off x="2341720" y="2057400"/>
+            <a:ext cx="675800" cy="0"/>
+          </a:xfrm>
+          <a:prstGeom prst="line">
+            <a:avLst/>
+          </a:prstGeom>
+          <a:ln w="19050">
+            <a:solidFill>
+              <a:srgbClr val="4472C4"/>
+            </a:solidFill>
+            <a:tailEnd type="triangle" w="lg" len="lg"/>
+          </a:ln>
+        </p:spPr>
+        <p:style>
+          <a:lnRef idx="2">
+            <a:schemeClr val="accent1"/>
+          </a:lnRef>
+          <a:fillRef idx="0">
+            <a:schemeClr val="accent1"/>
+          </a:fillRef>
+          <a:effectRef idx="1">
+            <a:schemeClr val="accent1"/>
+          </a:effectRef>
+          <a:fontRef idx="minor">
+            <a:schemeClr val="tx1"/>
+          </a:fontRef>
+        </p:style>
+      </p:cxnSp>
+      <p:sp>
+        <p:nvSpPr>
+          <p:cNvPr id="18" name="Oval 17"/>
+          <p:cNvSpPr/>
+          <p:nvPr/>
+        </p:nvSpPr>
+        <p:spPr>
+          <a:xfrm>
+            <a:off x="2321720" y="3144680"/>
+            <a:ext cx="20000" cy="20000"/>
+          </a:xfrm>
+          <a:prstGeom prst="ellipse">
+            <a:avLst/>
+          </a:prstGeom>
+          <a:solidFill>
+            <a:srgbClr val="4472C4"/>
+          </a:solidFill>
+          <a:ln>
+            <a:noFill/>
+          </a:ln>
+        </p:spPr>
+        <p:style>
+          <a:lnRef idx="1">
+            <a:schemeClr val="accent1"/>
+          </a:lnRef>
+          <a:fillRef idx="3">
+            <a:schemeClr val="accent1"/>
+          </a:fillRef>
+          <a:effectRef idx="2">
+            <a:schemeClr val="accent1"/>
+          </a:effectRef>
+          <a:fontRef idx="minor">
+            <a:schemeClr val="lt1"/>
+          </a:fontRef>
+        </p:style>
+        <p:txBody>
+          <a:bodyPr rtlCol="0" anchor="ctr"/>
+          <a:lstStyle/>
+          <a:p>
+            <a:pPr algn="ctr"/>
+          </a:p>
+        </p:txBody>
+      </p:sp>
+      <p:cxnSp>
+        <p:nvCxnSpPr>
+          <p:cNvPr id="19" name="Connector 18"/>
+          <p:cNvCxnSpPr/>
+          <p:nvPr/>
+        </p:nvCxnSpPr>
+        <p:spPr>
+          <a:xfrm>
+            <a:off x="2341720" y="3154680"/>
+            <a:ext cx="675800" cy="54864"/>
+          </a:xfrm>
+          <a:prstGeom prst="line">
+            <a:avLst/>
+          </a:prstGeom>
+          <a:ln w="19050">
+            <a:solidFill>
+              <a:srgbClr val="4472C4"/>
+            </a:solidFill>
+            <a:tailEnd type="triangle" w="lg" len="lg"/>
+          </a:ln>
+        </p:spPr>
+        <p:style>
+          <a:lnRef idx="2">
+            <a:schemeClr val="accent1"/>
+          </a:lnRef>
+          <a:fillRef idx="0">
+            <a:schemeClr val="accent1"/>
+          </a:fillRef>
+          <a:effectRef idx="1">
+            <a:schemeClr val="accent1"/>
+          </a:effectRef>
+          <a:fontRef idx="minor">
+            <a:schemeClr val="tx1"/>
+          </a:fontRef>
+        </p:style>
+      </p:cxnSp>
     </p:spTree>
   </p:cSld>
   <p:clrMapOvr>
@@ -3733,10 +4229,6 @@
       </a:style>
     </a:lnDef>
   </a:objectDefaults>
-  <a:extLst>
-    <a:ext uri="{05A4C25C-085E-4340-85A3-A5531E510DB2}">
-      <thm15:themeFamily xmlns:thm15="http://schemas.microsoft.com/office/thememl/2012/main" name="Office Theme" id="{62F939B6-93AF-4DB8-9C6B-D6C7DFDC589F}" vid="{4A3C46E8-61CC-4603-A589-7422A47A8E4A}"/>
-    </a:ext>
-  </a:extLst>
+  <a:extraClrSchemeLst/>
 </a:theme>
 </file>
</xml_diff>